<commit_message>
Prepare The Mentalist organizer submission package
</commit_message>
<xml_diff>
--- a/submission/presentation.pptx
+++ b/submission/presentation.pptx
@@ -2,18 +2,18 @@
 <file path=ppt/presentation.xml><?xml version="1.0" encoding="utf-8"?>
 <p:presentation xmlns:p="http://schemas.openxmlformats.org/presentationml/2006/main">
   <p:sldMasterIdLst>
-    <p:sldMasterId xmlns:r="http://schemas.openxmlformats.org/officeDocument/2006/relationships" id="2147483648" r:id="R5707095cd5334303"/>
+    <p:sldMasterId xmlns:r="http://schemas.openxmlformats.org/officeDocument/2006/relationships" id="2147483648" r:id="R59695eb93f894aa1"/>
   </p:sldMasterIdLst>
   <p:notesMasterIdLst>
-    <p:notesMasterId xmlns:r="http://schemas.openxmlformats.org/officeDocument/2006/relationships" r:id="R14f556dd23b04a10"/>
+    <p:notesMasterId xmlns:r="http://schemas.openxmlformats.org/officeDocument/2006/relationships" r:id="Rfb25bf4260784041"/>
   </p:notesMasterIdLst>
   <p:sldIdLst>
-    <p:sldId xmlns:r="http://schemas.openxmlformats.org/officeDocument/2006/relationships" id="256" r:id="R8d7389f1a02c430d"/>
-    <p:sldId xmlns:r="http://schemas.openxmlformats.org/officeDocument/2006/relationships" id="257" r:id="R3aabde255dd343b8"/>
-    <p:sldId xmlns:r="http://schemas.openxmlformats.org/officeDocument/2006/relationships" id="258" r:id="Rd8bd4eaa9b534c28"/>
-    <p:sldId xmlns:r="http://schemas.openxmlformats.org/officeDocument/2006/relationships" id="259" r:id="R54fdf9a07b5e465d"/>
-    <p:sldId xmlns:r="http://schemas.openxmlformats.org/officeDocument/2006/relationships" id="260" r:id="Rb722f362e3964104"/>
-    <p:sldId xmlns:r="http://schemas.openxmlformats.org/officeDocument/2006/relationships" id="261" r:id="R6dfe76db01274b49"/>
+    <p:sldId xmlns:r="http://schemas.openxmlformats.org/officeDocument/2006/relationships" id="256" r:id="R435147d3b8fe493f"/>
+    <p:sldId xmlns:r="http://schemas.openxmlformats.org/officeDocument/2006/relationships" id="257" r:id="Refa6767e42404b6d"/>
+    <p:sldId xmlns:r="http://schemas.openxmlformats.org/officeDocument/2006/relationships" id="258" r:id="R11d71b413b404f3e"/>
+    <p:sldId xmlns:r="http://schemas.openxmlformats.org/officeDocument/2006/relationships" id="259" r:id="R1be599f7d29f4311"/>
+    <p:sldId xmlns:r="http://schemas.openxmlformats.org/officeDocument/2006/relationships" id="260" r:id="R5bb1d70f51a144bb"/>
+    <p:sldId xmlns:r="http://schemas.openxmlformats.org/officeDocument/2006/relationships" id="261" r:id="R4e96b661afe84f1b"/>
   </p:sldIdLst>
   <p:sldSz cx="12192000" cy="6858000"/>
   <p:notesSz cx="6858000" cy="9144000"/>
@@ -447,12 +447,12 @@
           <a:lstStyle xmlns:a="http://schemas.openxmlformats.org/drawingml/2006/main"/>
           <a:p xmlns:a="http://schemas.openxmlformats.org/drawingml/2006/main">
             <a:r>
-              <a:t>0:00–0:20. We chose Case 3 from KRU and Qostanai Hub. Our prototype brings local webcam signals and exam-window events into one review timeline. The captain owns engineering and this pitch. Our second teammate owns testing and demonstration. A person reviews each alert and decides what it means.</a:t>
-            </a:r>
-          </a:p>
-          <a:p xmlns:a="http://schemas.openxmlformats.org/drawingml/2006/main">
-            <a:r>
-              <a:t>Sources: docs/CASE_AND_RULES.md, docs/TEAM_PLAN.md. These roles reflect the user’s latest instruction. No third member, personal names or university endorsement are claimed.</a:t>
+              <a:t>0:00–0:20. We are The Mentalist from Astana IT University in Astana: Artur Bulatov, captain, with Aibek Zainiddin and Adilet Derdybekov. We chose Case 3 from KRU and Qostanai Hub. Our prototype combines local webcam signals and exam-window events into one timeline for human review.</a:t>
+            </a:r>
+          </a:p>
+          <a:p xmlns:a="http://schemas.openxmlformats.org/drawingml/2006/main">
+            <a:r>
+              <a:t>Source: team details supplied directly by the user on 8 October 2026; docs/CASE_AND_RULES.md. The captain and Codex prepared the technical and pitch materials. Member roles beyond captain have not been independently verified.</a:t>
             </a:r>
           </a:p>
         </p:txBody>
@@ -930,6 +930,7 @@
                 <a:spcPts val="0"/>
               </a:spcAft>
               <a:buNone/>
+              <a:defRPr/>
             </a:lvl1pPr>
             <a:lvl2pPr marL="0" indent="0">
               <a:lnSpc>
@@ -942,6 +943,7 @@
                 <a:spcPts val="0"/>
               </a:spcAft>
               <a:buNone/>
+              <a:defRPr/>
             </a:lvl2pPr>
             <a:lvl3pPr marL="0" indent="0">
               <a:lnSpc>
@@ -954,6 +956,7 @@
                 <a:spcPts val="0"/>
               </a:spcAft>
               <a:buNone/>
+              <a:defRPr/>
             </a:lvl3pPr>
             <a:lvl4pPr marL="0" indent="0">
               <a:lnSpc>
@@ -966,6 +969,7 @@
                 <a:spcPts val="0"/>
               </a:spcAft>
               <a:buNone/>
+              <a:defRPr/>
             </a:lvl4pPr>
             <a:lvl5pPr marL="0" indent="0">
               <a:lnSpc>
@@ -978,6 +982,7 @@
                 <a:spcPts val="0"/>
               </a:spcAft>
               <a:buNone/>
+              <a:defRPr/>
             </a:lvl5pPr>
             <a:lvl6pPr marL="0" indent="0">
               <a:lnSpc>
@@ -990,6 +995,7 @@
                 <a:spcPts val="0"/>
               </a:spcAft>
               <a:buNone/>
+              <a:defRPr/>
             </a:lvl6pPr>
             <a:lvl7pPr marL="0" indent="0">
               <a:lnSpc>
@@ -1002,6 +1008,7 @@
                 <a:spcPts val="0"/>
               </a:spcAft>
               <a:buNone/>
+              <a:defRPr/>
             </a:lvl7pPr>
             <a:lvl8pPr marL="0" indent="0">
               <a:lnSpc>
@@ -1014,6 +1021,7 @@
                 <a:spcPts val="0"/>
               </a:spcAft>
               <a:buNone/>
+              <a:defRPr/>
             </a:lvl8pPr>
             <a:lvl9pPr marL="0" indent="0">
               <a:lnSpc>
@@ -1026,6 +1034,7 @@
                 <a:spcPts val="0"/>
               </a:spcAft>
               <a:buNone/>
+              <a:defRPr/>
             </a:lvl9pPr>
           </a:lstStyle>
           <a:p xmlns:a="http://schemas.openxmlformats.org/drawingml/2006/main"/>
@@ -1087,6 +1096,7 @@
                 <a:spcPts val="0"/>
               </a:spcAft>
               <a:buNone/>
+              <a:defRPr/>
             </a:lvl1pPr>
             <a:lvl2pPr marL="0" indent="0">
               <a:lnSpc>
@@ -1099,6 +1109,7 @@
                 <a:spcPts val="0"/>
               </a:spcAft>
               <a:buNone/>
+              <a:defRPr/>
             </a:lvl2pPr>
             <a:lvl3pPr marL="0" indent="0">
               <a:lnSpc>
@@ -1111,6 +1122,7 @@
                 <a:spcPts val="0"/>
               </a:spcAft>
               <a:buNone/>
+              <a:defRPr/>
             </a:lvl3pPr>
             <a:lvl4pPr marL="0" indent="0">
               <a:lnSpc>
@@ -1123,6 +1135,7 @@
                 <a:spcPts val="0"/>
               </a:spcAft>
               <a:buNone/>
+              <a:defRPr/>
             </a:lvl4pPr>
             <a:lvl5pPr marL="0" indent="0">
               <a:lnSpc>
@@ -1135,6 +1148,7 @@
                 <a:spcPts val="0"/>
               </a:spcAft>
               <a:buNone/>
+              <a:defRPr/>
             </a:lvl5pPr>
             <a:lvl6pPr marL="0" indent="0">
               <a:lnSpc>
@@ -1147,6 +1161,7 @@
                 <a:spcPts val="0"/>
               </a:spcAft>
               <a:buNone/>
+              <a:defRPr/>
             </a:lvl6pPr>
             <a:lvl7pPr marL="0" indent="0">
               <a:lnSpc>
@@ -1159,6 +1174,7 @@
                 <a:spcPts val="0"/>
               </a:spcAft>
               <a:buNone/>
+              <a:defRPr/>
             </a:lvl7pPr>
             <a:lvl8pPr marL="0" indent="0">
               <a:lnSpc>
@@ -1171,6 +1187,7 @@
                 <a:spcPts val="0"/>
               </a:spcAft>
               <a:buNone/>
+              <a:defRPr/>
             </a:lvl8pPr>
             <a:lvl9pPr marL="0" indent="0">
               <a:lnSpc>
@@ -1183,6 +1200,7 @@
                 <a:spcPts val="0"/>
               </a:spcAft>
               <a:buNone/>
+              <a:defRPr/>
             </a:lvl9pPr>
           </a:lstStyle>
           <a:p xmlns:a="http://schemas.openxmlformats.org/drawingml/2006/main"/>
@@ -1261,6 +1279,7 @@
                 <a:spcPts val="0"/>
               </a:spcAft>
               <a:buNone/>
+              <a:defRPr/>
             </a:lvl1pPr>
             <a:lvl2pPr marL="0" indent="0">
               <a:lnSpc>
@@ -1273,6 +1292,7 @@
                 <a:spcPts val="0"/>
               </a:spcAft>
               <a:buNone/>
+              <a:defRPr/>
             </a:lvl2pPr>
             <a:lvl3pPr marL="0" indent="0">
               <a:lnSpc>
@@ -1285,6 +1305,7 @@
                 <a:spcPts val="0"/>
               </a:spcAft>
               <a:buNone/>
+              <a:defRPr/>
             </a:lvl3pPr>
             <a:lvl4pPr marL="0" indent="0">
               <a:lnSpc>
@@ -1297,6 +1318,7 @@
                 <a:spcPts val="0"/>
               </a:spcAft>
               <a:buNone/>
+              <a:defRPr/>
             </a:lvl4pPr>
             <a:lvl5pPr marL="0" indent="0">
               <a:lnSpc>
@@ -1309,6 +1331,7 @@
                 <a:spcPts val="0"/>
               </a:spcAft>
               <a:buNone/>
+              <a:defRPr/>
             </a:lvl5pPr>
             <a:lvl6pPr marL="0" indent="0">
               <a:lnSpc>
@@ -1321,6 +1344,7 @@
                 <a:spcPts val="0"/>
               </a:spcAft>
               <a:buNone/>
+              <a:defRPr/>
             </a:lvl6pPr>
             <a:lvl7pPr marL="0" indent="0">
               <a:lnSpc>
@@ -1333,6 +1357,7 @@
                 <a:spcPts val="0"/>
               </a:spcAft>
               <a:buNone/>
+              <a:defRPr/>
             </a:lvl7pPr>
             <a:lvl8pPr marL="0" indent="0">
               <a:lnSpc>
@@ -1345,6 +1370,7 @@
                 <a:spcPts val="0"/>
               </a:spcAft>
               <a:buNone/>
+              <a:defRPr/>
             </a:lvl8pPr>
             <a:lvl9pPr marL="0" indent="0">
               <a:lnSpc>
@@ -1357,6 +1383,7 @@
                 <a:spcPts val="0"/>
               </a:spcAft>
               <a:buNone/>
+              <a:defRPr/>
             </a:lvl9pPr>
           </a:lstStyle>
           <a:p xmlns:a="http://schemas.openxmlformats.org/drawingml/2006/main"/>
@@ -1435,6 +1462,7 @@
                 <a:spcPts val="0"/>
               </a:spcAft>
               <a:buNone/>
+              <a:defRPr/>
             </a:lvl1pPr>
             <a:lvl2pPr marL="0" indent="0">
               <a:lnSpc>
@@ -1447,6 +1475,7 @@
                 <a:spcPts val="0"/>
               </a:spcAft>
               <a:buNone/>
+              <a:defRPr/>
             </a:lvl2pPr>
             <a:lvl3pPr marL="0" indent="0">
               <a:lnSpc>
@@ -1459,6 +1488,7 @@
                 <a:spcPts val="0"/>
               </a:spcAft>
               <a:buNone/>
+              <a:defRPr/>
             </a:lvl3pPr>
             <a:lvl4pPr marL="0" indent="0">
               <a:lnSpc>
@@ -1471,6 +1501,7 @@
                 <a:spcPts val="0"/>
               </a:spcAft>
               <a:buNone/>
+              <a:defRPr/>
             </a:lvl4pPr>
             <a:lvl5pPr marL="0" indent="0">
               <a:lnSpc>
@@ -1483,6 +1514,7 @@
                 <a:spcPts val="0"/>
               </a:spcAft>
               <a:buNone/>
+              <a:defRPr/>
             </a:lvl5pPr>
             <a:lvl6pPr marL="0" indent="0">
               <a:lnSpc>
@@ -1495,6 +1527,7 @@
                 <a:spcPts val="0"/>
               </a:spcAft>
               <a:buNone/>
+              <a:defRPr/>
             </a:lvl6pPr>
             <a:lvl7pPr marL="0" indent="0">
               <a:lnSpc>
@@ -1507,6 +1540,7 @@
                 <a:spcPts val="0"/>
               </a:spcAft>
               <a:buNone/>
+              <a:defRPr/>
             </a:lvl7pPr>
             <a:lvl8pPr marL="0" indent="0">
               <a:lnSpc>
@@ -1519,6 +1553,7 @@
                 <a:spcPts val="0"/>
               </a:spcAft>
               <a:buNone/>
+              <a:defRPr/>
             </a:lvl8pPr>
             <a:lvl9pPr marL="0" indent="0">
               <a:lnSpc>
@@ -1531,6 +1566,7 @@
                 <a:spcPts val="0"/>
               </a:spcAft>
               <a:buNone/>
+              <a:defRPr/>
             </a:lvl9pPr>
           </a:lstStyle>
           <a:p xmlns:a="http://schemas.openxmlformats.org/drawingml/2006/main"/>
@@ -1592,6 +1628,7 @@
                 <a:spcPts val="1200"/>
               </a:spcAft>
               <a:buChar char="•"/>
+              <a:defRPr/>
             </a:lvl1pPr>
             <a:lvl2pPr marL="533400" indent="-228600">
               <a:lnSpc>
@@ -1604,6 +1641,7 @@
                 <a:spcPts val="1200"/>
               </a:spcAft>
               <a:buChar char="•"/>
+              <a:defRPr/>
             </a:lvl2pPr>
             <a:lvl3pPr marL="838200" indent="-228600">
               <a:lnSpc>
@@ -1616,6 +1654,7 @@
                 <a:spcPts val="1200"/>
               </a:spcAft>
               <a:buChar char="•"/>
+              <a:defRPr/>
             </a:lvl3pPr>
             <a:lvl4pPr marL="1143000" indent="-228600">
               <a:lnSpc>
@@ -1628,6 +1667,7 @@
                 <a:spcPts val="1200"/>
               </a:spcAft>
               <a:buChar char="•"/>
+              <a:defRPr/>
             </a:lvl4pPr>
             <a:lvl5pPr marL="1447800" indent="-228600">
               <a:lnSpc>
@@ -1640,6 +1680,7 @@
                 <a:spcPts val="1200"/>
               </a:spcAft>
               <a:buChar char="•"/>
+              <a:defRPr/>
             </a:lvl5pPr>
             <a:lvl6pPr marL="1752600" indent="-228600">
               <a:lnSpc>
@@ -1652,6 +1693,7 @@
                 <a:spcPts val="1200"/>
               </a:spcAft>
               <a:buChar char="•"/>
+              <a:defRPr/>
             </a:lvl6pPr>
             <a:lvl7pPr marL="2057400" indent="-228600">
               <a:lnSpc>
@@ -1664,6 +1706,7 @@
                 <a:spcPts val="1200"/>
               </a:spcAft>
               <a:buChar char="•"/>
+              <a:defRPr/>
             </a:lvl7pPr>
             <a:lvl8pPr marL="2362200" indent="-228600">
               <a:lnSpc>
@@ -1676,6 +1719,7 @@
                 <a:spcPts val="1200"/>
               </a:spcAft>
               <a:buChar char="•"/>
+              <a:defRPr/>
             </a:lvl8pPr>
             <a:lvl9pPr marL="2667000" indent="-228600">
               <a:lnSpc>
@@ -1688,6 +1732,7 @@
                 <a:spcPts val="1200"/>
               </a:spcAft>
               <a:buChar char="•"/>
+              <a:defRPr/>
             </a:lvl9pPr>
           </a:lstStyle>
           <a:p xmlns:a="http://schemas.openxmlformats.org/drawingml/2006/main"/>
@@ -1766,6 +1811,7 @@
                 <a:spcPts val="0"/>
               </a:spcAft>
               <a:buNone/>
+              <a:defRPr/>
             </a:lvl1pPr>
             <a:lvl2pPr marL="0" indent="0">
               <a:lnSpc>
@@ -1778,6 +1824,7 @@
                 <a:spcPts val="0"/>
               </a:spcAft>
               <a:buNone/>
+              <a:defRPr/>
             </a:lvl2pPr>
             <a:lvl3pPr marL="0" indent="0">
               <a:lnSpc>
@@ -1790,6 +1837,7 @@
                 <a:spcPts val="0"/>
               </a:spcAft>
               <a:buNone/>
+              <a:defRPr/>
             </a:lvl3pPr>
             <a:lvl4pPr marL="0" indent="0">
               <a:lnSpc>
@@ -1802,6 +1850,7 @@
                 <a:spcPts val="0"/>
               </a:spcAft>
               <a:buNone/>
+              <a:defRPr/>
             </a:lvl4pPr>
             <a:lvl5pPr marL="0" indent="0">
               <a:lnSpc>
@@ -1814,6 +1863,7 @@
                 <a:spcPts val="0"/>
               </a:spcAft>
               <a:buNone/>
+              <a:defRPr/>
             </a:lvl5pPr>
             <a:lvl6pPr marL="0" indent="0">
               <a:lnSpc>
@@ -1826,6 +1876,7 @@
                 <a:spcPts val="0"/>
               </a:spcAft>
               <a:buNone/>
+              <a:defRPr/>
             </a:lvl6pPr>
             <a:lvl7pPr marL="0" indent="0">
               <a:lnSpc>
@@ -1838,6 +1889,7 @@
                 <a:spcPts val="0"/>
               </a:spcAft>
               <a:buNone/>
+              <a:defRPr/>
             </a:lvl7pPr>
             <a:lvl8pPr marL="0" indent="0">
               <a:lnSpc>
@@ -1850,6 +1902,7 @@
                 <a:spcPts val="0"/>
               </a:spcAft>
               <a:buNone/>
+              <a:defRPr/>
             </a:lvl8pPr>
             <a:lvl9pPr marL="0" indent="0">
               <a:lnSpc>
@@ -1862,6 +1915,7 @@
                 <a:spcPts val="0"/>
               </a:spcAft>
               <a:buNone/>
+              <a:defRPr/>
             </a:lvl9pPr>
           </a:lstStyle>
           <a:p xmlns:a="http://schemas.openxmlformats.org/drawingml/2006/main"/>
@@ -1923,6 +1977,7 @@
                 <a:spcPts val="1200"/>
               </a:spcAft>
               <a:buChar char="•"/>
+              <a:defRPr/>
             </a:lvl1pPr>
             <a:lvl2pPr marL="533400" indent="-228600">
               <a:lnSpc>
@@ -1935,6 +1990,7 @@
                 <a:spcPts val="1200"/>
               </a:spcAft>
               <a:buChar char="•"/>
+              <a:defRPr/>
             </a:lvl2pPr>
             <a:lvl3pPr marL="838200" indent="-228600">
               <a:lnSpc>
@@ -1947,6 +2003,7 @@
                 <a:spcPts val="1200"/>
               </a:spcAft>
               <a:buChar char="•"/>
+              <a:defRPr/>
             </a:lvl3pPr>
             <a:lvl4pPr marL="1143000" indent="-228600">
               <a:lnSpc>
@@ -1959,6 +2016,7 @@
                 <a:spcPts val="1200"/>
               </a:spcAft>
               <a:buChar char="•"/>
+              <a:defRPr/>
             </a:lvl4pPr>
             <a:lvl5pPr marL="1447800" indent="-228600">
               <a:lnSpc>
@@ -1971,6 +2029,7 @@
                 <a:spcPts val="1200"/>
               </a:spcAft>
               <a:buChar char="•"/>
+              <a:defRPr/>
             </a:lvl5pPr>
             <a:lvl6pPr marL="1752600" indent="-228600">
               <a:lnSpc>
@@ -1983,6 +2042,7 @@
                 <a:spcPts val="1200"/>
               </a:spcAft>
               <a:buChar char="•"/>
+              <a:defRPr/>
             </a:lvl6pPr>
             <a:lvl7pPr marL="2057400" indent="-228600">
               <a:lnSpc>
@@ -1995,6 +2055,7 @@
                 <a:spcPts val="1200"/>
               </a:spcAft>
               <a:buChar char="•"/>
+              <a:defRPr/>
             </a:lvl7pPr>
             <a:lvl8pPr marL="2362200" indent="-228600">
               <a:lnSpc>
@@ -2007,6 +2068,7 @@
                 <a:spcPts val="1200"/>
               </a:spcAft>
               <a:buChar char="•"/>
+              <a:defRPr/>
             </a:lvl8pPr>
             <a:lvl9pPr marL="2667000" indent="-228600">
               <a:lnSpc>
@@ -2019,6 +2081,7 @@
                 <a:spcPts val="1200"/>
               </a:spcAft>
               <a:buChar char="•"/>
+              <a:defRPr/>
             </a:lvl9pPr>
           </a:lstStyle>
           <a:p xmlns:a="http://schemas.openxmlformats.org/drawingml/2006/main"/>
@@ -2080,6 +2143,7 @@
                 <a:spcPts val="1200"/>
               </a:spcAft>
               <a:buChar char="•"/>
+              <a:defRPr/>
             </a:lvl1pPr>
             <a:lvl2pPr marL="533400" indent="-228600">
               <a:lnSpc>
@@ -2092,6 +2156,7 @@
                 <a:spcPts val="1200"/>
               </a:spcAft>
               <a:buChar char="•"/>
+              <a:defRPr/>
             </a:lvl2pPr>
             <a:lvl3pPr marL="838200" indent="-228600">
               <a:lnSpc>
@@ -2104,6 +2169,7 @@
                 <a:spcPts val="1200"/>
               </a:spcAft>
               <a:buChar char="•"/>
+              <a:defRPr/>
             </a:lvl3pPr>
             <a:lvl4pPr marL="1143000" indent="-228600">
               <a:lnSpc>
@@ -2116,6 +2182,7 @@
                 <a:spcPts val="1200"/>
               </a:spcAft>
               <a:buChar char="•"/>
+              <a:defRPr/>
             </a:lvl4pPr>
             <a:lvl5pPr marL="1447800" indent="-228600">
               <a:lnSpc>
@@ -2128,6 +2195,7 @@
                 <a:spcPts val="1200"/>
               </a:spcAft>
               <a:buChar char="•"/>
+              <a:defRPr/>
             </a:lvl5pPr>
             <a:lvl6pPr marL="1752600" indent="-228600">
               <a:lnSpc>
@@ -2140,6 +2208,7 @@
                 <a:spcPts val="1200"/>
               </a:spcAft>
               <a:buChar char="•"/>
+              <a:defRPr/>
             </a:lvl6pPr>
             <a:lvl7pPr marL="2057400" indent="-228600">
               <a:lnSpc>
@@ -2152,6 +2221,7 @@
                 <a:spcPts val="1200"/>
               </a:spcAft>
               <a:buChar char="•"/>
+              <a:defRPr/>
             </a:lvl7pPr>
             <a:lvl8pPr marL="2362200" indent="-228600">
               <a:lnSpc>
@@ -2164,6 +2234,7 @@
                 <a:spcPts val="1200"/>
               </a:spcAft>
               <a:buChar char="•"/>
+              <a:defRPr/>
             </a:lvl8pPr>
             <a:lvl9pPr marL="2667000" indent="-228600">
               <a:lnSpc>
@@ -2176,6 +2247,7 @@
                 <a:spcPts val="1200"/>
               </a:spcAft>
               <a:buChar char="•"/>
+              <a:defRPr/>
             </a:lvl9pPr>
           </a:lstStyle>
           <a:p xmlns:a="http://schemas.openxmlformats.org/drawingml/2006/main"/>
@@ -2254,6 +2326,7 @@
                 <a:spcPts val="0"/>
               </a:spcAft>
               <a:buNone/>
+              <a:defRPr/>
             </a:lvl1pPr>
             <a:lvl2pPr marL="0" indent="0">
               <a:lnSpc>
@@ -2266,6 +2339,7 @@
                 <a:spcPts val="0"/>
               </a:spcAft>
               <a:buNone/>
+              <a:defRPr/>
             </a:lvl2pPr>
             <a:lvl3pPr marL="0" indent="0">
               <a:lnSpc>
@@ -2278,6 +2352,7 @@
                 <a:spcPts val="0"/>
               </a:spcAft>
               <a:buNone/>
+              <a:defRPr/>
             </a:lvl3pPr>
             <a:lvl4pPr marL="0" indent="0">
               <a:lnSpc>
@@ -2290,6 +2365,7 @@
                 <a:spcPts val="0"/>
               </a:spcAft>
               <a:buNone/>
+              <a:defRPr/>
             </a:lvl4pPr>
             <a:lvl5pPr marL="0" indent="0">
               <a:lnSpc>
@@ -2302,6 +2378,7 @@
                 <a:spcPts val="0"/>
               </a:spcAft>
               <a:buNone/>
+              <a:defRPr/>
             </a:lvl5pPr>
             <a:lvl6pPr marL="0" indent="0">
               <a:lnSpc>
@@ -2314,6 +2391,7 @@
                 <a:spcPts val="0"/>
               </a:spcAft>
               <a:buNone/>
+              <a:defRPr/>
             </a:lvl6pPr>
             <a:lvl7pPr marL="0" indent="0">
               <a:lnSpc>
@@ -2326,6 +2404,7 @@
                 <a:spcPts val="0"/>
               </a:spcAft>
               <a:buNone/>
+              <a:defRPr/>
             </a:lvl7pPr>
             <a:lvl8pPr marL="0" indent="0">
               <a:lnSpc>
@@ -2338,6 +2417,7 @@
                 <a:spcPts val="0"/>
               </a:spcAft>
               <a:buNone/>
+              <a:defRPr/>
             </a:lvl8pPr>
             <a:lvl9pPr marL="0" indent="0">
               <a:lnSpc>
@@ -2350,6 +2430,7 @@
                 <a:spcPts val="0"/>
               </a:spcAft>
               <a:buNone/>
+              <a:defRPr/>
             </a:lvl9pPr>
           </a:lstStyle>
           <a:p xmlns:a="http://schemas.openxmlformats.org/drawingml/2006/main"/>
@@ -2411,6 +2492,7 @@
                 <a:spcPts val="1200"/>
               </a:spcAft>
               <a:buChar char="•"/>
+              <a:defRPr/>
             </a:lvl1pPr>
             <a:lvl2pPr marL="533400" indent="-228600">
               <a:lnSpc>
@@ -2423,6 +2505,7 @@
                 <a:spcPts val="1200"/>
               </a:spcAft>
               <a:buChar char="•"/>
+              <a:defRPr/>
             </a:lvl2pPr>
             <a:lvl3pPr marL="838200" indent="-228600">
               <a:lnSpc>
@@ -2435,6 +2518,7 @@
                 <a:spcPts val="1200"/>
               </a:spcAft>
               <a:buChar char="•"/>
+              <a:defRPr/>
             </a:lvl3pPr>
             <a:lvl4pPr marL="1143000" indent="-228600">
               <a:lnSpc>
@@ -2447,6 +2531,7 @@
                 <a:spcPts val="1200"/>
               </a:spcAft>
               <a:buChar char="•"/>
+              <a:defRPr/>
             </a:lvl4pPr>
             <a:lvl5pPr marL="1447800" indent="-228600">
               <a:lnSpc>
@@ -2459,6 +2544,7 @@
                 <a:spcPts val="1200"/>
               </a:spcAft>
               <a:buChar char="•"/>
+              <a:defRPr/>
             </a:lvl5pPr>
             <a:lvl6pPr marL="1752600" indent="-228600">
               <a:lnSpc>
@@ -2471,6 +2557,7 @@
                 <a:spcPts val="1200"/>
               </a:spcAft>
               <a:buChar char="•"/>
+              <a:defRPr/>
             </a:lvl6pPr>
             <a:lvl7pPr marL="2057400" indent="-228600">
               <a:lnSpc>
@@ -2483,6 +2570,7 @@
                 <a:spcPts val="1200"/>
               </a:spcAft>
               <a:buChar char="•"/>
+              <a:defRPr/>
             </a:lvl7pPr>
             <a:lvl8pPr marL="2362200" indent="-228600">
               <a:lnSpc>
@@ -2495,6 +2583,7 @@
                 <a:spcPts val="1200"/>
               </a:spcAft>
               <a:buChar char="•"/>
+              <a:defRPr/>
             </a:lvl8pPr>
             <a:lvl9pPr marL="2667000" indent="-228600">
               <a:lnSpc>
@@ -2507,6 +2596,7 @@
                 <a:spcPts val="1200"/>
               </a:spcAft>
               <a:buChar char="•"/>
+              <a:defRPr/>
             </a:lvl9pPr>
           </a:lstStyle>
           <a:p xmlns:a="http://schemas.openxmlformats.org/drawingml/2006/main"/>
@@ -2555,12 +2645,12 @@
   </p:cSld>
   <p:clrMap bg1="lt1" tx1="dk1" bg2="lt2" tx2="dk2" accent1="accent1" accent2="accent2" accent3="accent3" accent4="accent4" accent5="accent5" accent6="accent6" hlink="hlink" folHlink="folHlink"/>
   <p:sldLayoutIdLst>
-    <p:sldLayoutId xmlns:r="http://schemas.openxmlformats.org/officeDocument/2006/relationships" id="2147483649" r:id="R8c8c64fc478446b4"/>
-    <p:sldLayoutId xmlns:r="http://schemas.openxmlformats.org/officeDocument/2006/relationships" id="2147483650" r:id="R1c62fe0b977d48f9"/>
-    <p:sldLayoutId xmlns:r="http://schemas.openxmlformats.org/officeDocument/2006/relationships" id="2147483651" r:id="R5fc3a343dd874e53"/>
-    <p:sldLayoutId xmlns:r="http://schemas.openxmlformats.org/officeDocument/2006/relationships" id="2147483652" r:id="R469e882839ce4c35"/>
-    <p:sldLayoutId xmlns:r="http://schemas.openxmlformats.org/officeDocument/2006/relationships" id="2147483653" r:id="Rb57f5fbcfbec4ab6"/>
-    <p:sldLayoutId xmlns:r="http://schemas.openxmlformats.org/officeDocument/2006/relationships" id="2147483654" r:id="R867b2081756349ad"/>
+    <p:sldLayoutId xmlns:r="http://schemas.openxmlformats.org/officeDocument/2006/relationships" id="2147483649" r:id="R67a767d5ed1b43da"/>
+    <p:sldLayoutId xmlns:r="http://schemas.openxmlformats.org/officeDocument/2006/relationships" id="2147483650" r:id="Rbd70dcd9d4e643b1"/>
+    <p:sldLayoutId xmlns:r="http://schemas.openxmlformats.org/officeDocument/2006/relationships" id="2147483651" r:id="R8af4c71ddd02465a"/>
+    <p:sldLayoutId xmlns:r="http://schemas.openxmlformats.org/officeDocument/2006/relationships" id="2147483652" r:id="R1a9b89b31d6a4deb"/>
+    <p:sldLayoutId xmlns:r="http://schemas.openxmlformats.org/officeDocument/2006/relationships" id="2147483653" r:id="R0bff47d27c8241e7"/>
+    <p:sldLayoutId xmlns:r="http://schemas.openxmlformats.org/officeDocument/2006/relationships" id="2147483654" r:id="R9b6c3792add94d1e"/>
   </p:sldLayoutIdLst>
   <p:txStyles>
     <p:titleStyle>
@@ -3149,6 +3239,7 @@
           </a:lstStyle>
           <a:p xmlns:a="http://schemas.openxmlformats.org/drawingml/2006/main">
             <a:pPr>
+              <a:buNone/>
               <a:defRPr sz="1350" b="0">
                 <a:solidFill>
                   <a:srgbClr val="BDC9BF"/>
@@ -3215,6 +3306,7 @@
           </a:lstStyle>
           <a:p xmlns:a="http://schemas.openxmlformats.org/drawingml/2006/main">
             <a:pPr>
+              <a:buNone/>
               <a:defRPr sz="1725" b="1">
                 <a:solidFill>
                   <a:srgbClr val="C2EF7A"/>
@@ -3233,7 +3325,7 @@
                 <a:ea typeface="Arial"/>
                 <a:cs typeface="Arial"/>
               </a:rPr>
-              <a:t>CASE 3 / KRU AND QOSTANAI HUB</a:t>
+              <a:t>THE MENTALIST / ASTANA / CASE 3</a:t>
             </a:r>
           </a:p>
         </p:txBody>
@@ -3281,6 +3373,7 @@
           </a:lstStyle>
           <a:p xmlns:a="http://schemas.openxmlformats.org/drawingml/2006/main">
             <a:pPr>
+              <a:buNone/>
               <a:defRPr sz="5700" b="1">
                 <a:solidFill>
                   <a:srgbClr val="F5F5EB"/>
@@ -3304,6 +3397,7 @@
           </a:p>
           <a:p xmlns:a="http://schemas.openxmlformats.org/drawingml/2006/main">
             <a:pPr>
+              <a:buNone/>
               <a:defRPr sz="5700" b="1">
                 <a:solidFill>
                   <a:srgbClr val="F5F5EB"/>
@@ -3370,6 +3464,7 @@
           </a:lstStyle>
           <a:p xmlns:a="http://schemas.openxmlformats.org/drawingml/2006/main">
             <a:pPr>
+              <a:buNone/>
               <a:defRPr sz="2625" b="0">
                 <a:solidFill>
                   <a:srgbClr val="C2EF7A"/>
@@ -3436,6 +3531,7 @@
           </a:lstStyle>
           <a:p xmlns:a="http://schemas.openxmlformats.org/drawingml/2006/main">
             <a:pPr>
+              <a:buNone/>
               <a:defRPr sz="2325" b="0">
                 <a:solidFill>
                   <a:srgbClr val="F5F5EB"/>
@@ -3459,6 +3555,7 @@
           </a:p>
           <a:p xmlns:a="http://schemas.openxmlformats.org/drawingml/2006/main">
             <a:pPr>
+              <a:buNone/>
               <a:defRPr sz="2325" b="0">
                 <a:solidFill>
                   <a:srgbClr val="F5F5EB"/>
@@ -3525,6 +3622,7 @@
           </a:lstStyle>
           <a:p xmlns:a="http://schemas.openxmlformats.org/drawingml/2006/main">
             <a:pPr>
+              <a:buNone/>
               <a:defRPr sz="1725" b="0">
                 <a:solidFill>
                   <a:srgbClr val="BDC9BF"/>
@@ -3543,11 +3641,12 @@
                 <a:ea typeface="Arial"/>
                 <a:cs typeface="Arial"/>
               </a:rPr>
-              <a:t>Our roles: captain owns engineering and pitch.</a:t>
+              <a:t>Astana IT University</a:t>
             </a:r>
           </a:p>
           <a:p xmlns:a="http://schemas.openxmlformats.org/drawingml/2006/main">
             <a:pPr>
+              <a:buNone/>
               <a:defRPr sz="1725" b="0">
                 <a:solidFill>
                   <a:srgbClr val="BDC9BF"/>
@@ -3566,7 +3665,7 @@
                 <a:ea typeface="Arial"/>
                 <a:cs typeface="Arial"/>
               </a:rPr>
-              <a:t>Member 2 owns QA and demo operation. Codex assists development.</a:t>
+              <a:t>Artur Bulatov (captain), Aibek Zainiddin, Adilet Derdybekov</a:t>
             </a:r>
           </a:p>
         </p:txBody>
@@ -3643,6 +3742,7 @@
           </a:lstStyle>
           <a:p xmlns:a="http://schemas.openxmlformats.org/drawingml/2006/main">
             <a:pPr>
+              <a:buNone/>
               <a:defRPr sz="3600" b="1">
                 <a:solidFill>
                   <a:srgbClr val="F5F5EB"/>
@@ -3709,6 +3809,7 @@
           </a:lstStyle>
           <a:p xmlns:a="http://schemas.openxmlformats.org/drawingml/2006/main">
             <a:pPr>
+              <a:buNone/>
               <a:defRPr sz="1350" b="0">
                 <a:solidFill>
                   <a:srgbClr val="BDC9BF"/>
@@ -3737,7 +3838,7 @@
           <p:cNvPr id="3" name="">
             <a:extLst xmlns:a="http://schemas.openxmlformats.org/drawingml/2006/main">
               <a:ext uri="{FF2B5EF4-FFF2-40B4-BE49-F238E27FC236}">
-                <a16:creationId xmlns:a16="http://schemas.microsoft.com/office/drawing/2014/main" id="{31A06558-E593-466F-AD35-C1D777BC002A}"/>
+                <a16:creationId xmlns:a16="http://schemas.microsoft.com/office/drawing/2014/main" id="{4380CC53-169A-45DC-88DF-286E60F154D4}"/>
               </a:ext>
             </a:extLst>
           </p:cNvPr>
@@ -4213,6 +4314,7 @@
           </a:lstStyle>
           <a:p xmlns:a="http://schemas.openxmlformats.org/drawingml/2006/main">
             <a:pPr>
+              <a:buNone/>
               <a:defRPr sz="2025" b="0">
                 <a:solidFill>
                   <a:srgbClr val="C2EF7A"/>
@@ -4308,6 +4410,7 @@
           </a:lstStyle>
           <a:p xmlns:a="http://schemas.openxmlformats.org/drawingml/2006/main">
             <a:pPr>
+              <a:buNone/>
               <a:defRPr sz="3600" b="1">
                 <a:solidFill>
                   <a:srgbClr val="F5F5EB"/>
@@ -4374,6 +4477,7 @@
           </a:lstStyle>
           <a:p xmlns:a="http://schemas.openxmlformats.org/drawingml/2006/main">
             <a:pPr>
+              <a:buNone/>
               <a:defRPr sz="1350" b="0">
                 <a:solidFill>
                   <a:srgbClr val="BDC9BF"/>
@@ -4444,6 +4548,7 @@
           </a:lstStyle>
           <a:p xmlns:a="http://schemas.openxmlformats.org/drawingml/2006/main">
             <a:pPr algn="ctr">
+              <a:buNone/>
               <a:defRPr sz="1950">
                 <a:solidFill>
                   <a:srgbClr val="F5F5EB"/>
@@ -4467,6 +4572,7 @@
           </a:p>
           <a:p xmlns:a="http://schemas.openxmlformats.org/drawingml/2006/main">
             <a:pPr algn="ctr">
+              <a:buNone/>
               <a:defRPr sz="1950">
                 <a:solidFill>
                   <a:srgbClr val="F5F5EB"/>
@@ -4567,6 +4673,7 @@
           </a:lstStyle>
           <a:p xmlns:a="http://schemas.openxmlformats.org/drawingml/2006/main">
             <a:pPr algn="ctr">
+              <a:buNone/>
               <a:defRPr sz="1950">
                 <a:solidFill>
                   <a:srgbClr val="F5F5EB"/>
@@ -4590,6 +4697,7 @@
           </a:p>
           <a:p xmlns:a="http://schemas.openxmlformats.org/drawingml/2006/main">
             <a:pPr algn="ctr">
+              <a:buNone/>
               <a:defRPr sz="1950">
                 <a:solidFill>
                   <a:srgbClr val="F5F5EB"/>
@@ -4690,6 +4798,7 @@
           </a:lstStyle>
           <a:p xmlns:a="http://schemas.openxmlformats.org/drawingml/2006/main">
             <a:pPr algn="ctr">
+              <a:buNone/>
               <a:defRPr sz="1950">
                 <a:solidFill>
                   <a:srgbClr val="F5F5EB"/>
@@ -4713,6 +4822,7 @@
           </a:p>
           <a:p xmlns:a="http://schemas.openxmlformats.org/drawingml/2006/main">
             <a:pPr algn="ctr">
+              <a:buNone/>
               <a:defRPr sz="1950">
                 <a:solidFill>
                   <a:srgbClr val="F5F5EB"/>
@@ -4813,6 +4923,7 @@
           </a:lstStyle>
           <a:p xmlns:a="http://schemas.openxmlformats.org/drawingml/2006/main">
             <a:pPr algn="ctr">
+              <a:buNone/>
               <a:defRPr sz="1950">
                 <a:solidFill>
                   <a:srgbClr val="F5F5EB"/>
@@ -4836,6 +4947,7 @@
           </a:p>
           <a:p xmlns:a="http://schemas.openxmlformats.org/drawingml/2006/main">
             <a:pPr algn="ctr">
+              <a:buNone/>
               <a:defRPr sz="1950">
                 <a:solidFill>
                   <a:srgbClr val="F5F5EB"/>
@@ -4906,6 +5018,7 @@
           </a:lstStyle>
           <a:p xmlns:a="http://schemas.openxmlformats.org/drawingml/2006/main">
             <a:pPr algn="ctr">
+              <a:buNone/>
               <a:defRPr sz="1950">
                 <a:solidFill>
                   <a:srgbClr val="F5F5EB"/>
@@ -4929,6 +5042,7 @@
           </a:p>
           <a:p xmlns:a="http://schemas.openxmlformats.org/drawingml/2006/main">
             <a:pPr algn="ctr">
+              <a:buNone/>
               <a:defRPr sz="1950">
                 <a:solidFill>
                   <a:srgbClr val="F5F5EB"/>
@@ -4999,6 +5113,7 @@
           </a:lstStyle>
           <a:p xmlns:a="http://schemas.openxmlformats.org/drawingml/2006/main">
             <a:pPr algn="ctr">
+              <a:buNone/>
               <a:defRPr sz="1950">
                 <a:solidFill>
                   <a:srgbClr val="F5F5EB"/>
@@ -5022,6 +5137,7 @@
           </a:p>
           <a:p xmlns:a="http://schemas.openxmlformats.org/drawingml/2006/main">
             <a:pPr algn="ctr">
+              <a:buNone/>
               <a:defRPr sz="1950">
                 <a:solidFill>
                   <a:srgbClr val="F5F5EB"/>
@@ -5118,6 +5234,7 @@
           </a:lstStyle>
           <a:p xmlns:a="http://schemas.openxmlformats.org/drawingml/2006/main">
             <a:pPr>
+              <a:buNone/>
               <a:defRPr sz="2175" b="0">
                 <a:solidFill>
                   <a:srgbClr val="F5F5EB"/>
@@ -5141,6 +5258,7 @@
           </a:p>
           <a:p xmlns:a="http://schemas.openxmlformats.org/drawingml/2006/main">
             <a:pPr>
+              <a:buNone/>
               <a:defRPr sz="2175" b="0">
                 <a:solidFill>
                   <a:srgbClr val="F5F5EB"/>
@@ -5207,6 +5325,7 @@
           </a:lstStyle>
           <a:p xmlns:a="http://schemas.openxmlformats.org/drawingml/2006/main">
             <a:pPr>
+              <a:buNone/>
               <a:defRPr sz="1800" b="0">
                 <a:solidFill>
                   <a:srgbClr val="C2EF7A"/>
@@ -5302,6 +5421,7 @@
           </a:lstStyle>
           <a:p xmlns:a="http://schemas.openxmlformats.org/drawingml/2006/main">
             <a:pPr>
+              <a:buNone/>
               <a:defRPr sz="3600" b="1">
                 <a:solidFill>
                   <a:srgbClr val="F5F5EB"/>
@@ -5368,6 +5488,7 @@
           </a:lstStyle>
           <a:p xmlns:a="http://schemas.openxmlformats.org/drawingml/2006/main">
             <a:pPr>
+              <a:buNone/>
               <a:defRPr sz="1350" b="0">
                 <a:solidFill>
                   <a:srgbClr val="BDC9BF"/>
@@ -5396,7 +5517,7 @@
           <p:cNvPr id="3" name="">
             <a:extLst xmlns:a="http://schemas.openxmlformats.org/drawingml/2006/main">
               <a:ext uri="{FF2B5EF4-FFF2-40B4-BE49-F238E27FC236}">
-                <a16:creationId xmlns:a16="http://schemas.microsoft.com/office/drawing/2014/main" id="{45922914-C6BC-4088-AEC4-4E658A8A8114}"/>
+                <a16:creationId xmlns:a16="http://schemas.microsoft.com/office/drawing/2014/main" id="{0A80483F-9C59-4789-8471-8F547232E2E3}"/>
               </a:ext>
             </a:extLst>
           </p:cNvPr>
@@ -5406,7 +5527,7 @@
           <p:nvPr/>
         </p:nvPicPr>
         <p:blipFill>
-          <a:blip xmlns:r="http://schemas.openxmlformats.org/officeDocument/2006/relationships" xmlns:a="http://schemas.openxmlformats.org/drawingml/2006/main" r:embed="Rc4623590fde14f7b"/>
+          <a:blip xmlns:r="http://schemas.openxmlformats.org/officeDocument/2006/relationships" xmlns:a="http://schemas.openxmlformats.org/drawingml/2006/main" r:embed="Rc912525986f647bf"/>
           <a:stretch xmlns:a="http://schemas.openxmlformats.org/drawingml/2006/main"/>
         </p:blipFill>
         <p:spPr>
@@ -5462,6 +5583,7 @@
           </a:lstStyle>
           <a:p xmlns:a="http://schemas.openxmlformats.org/drawingml/2006/main">
             <a:pPr>
+              <a:buNone/>
               <a:defRPr sz="1650" b="1">
                 <a:solidFill>
                   <a:srgbClr val="E5BC83"/>
@@ -5528,6 +5650,7 @@
           </a:lstStyle>
           <a:p xmlns:a="http://schemas.openxmlformats.org/drawingml/2006/main">
             <a:pPr>
+              <a:buNone/>
               <a:defRPr sz="2400" b="1">
                 <a:solidFill>
                   <a:srgbClr val="C2EF7A"/>
@@ -5551,6 +5674,7 @@
           </a:p>
           <a:p xmlns:a="http://schemas.openxmlformats.org/drawingml/2006/main">
             <a:pPr>
+              <a:buNone/>
               <a:defRPr sz="2400" b="1">
                 <a:solidFill>
                   <a:srgbClr val="C2EF7A"/>
@@ -5617,6 +5741,7 @@
           </a:lstStyle>
           <a:p xmlns:a="http://schemas.openxmlformats.org/drawingml/2006/main">
             <a:pPr>
+              <a:buNone/>
               <a:defRPr sz="1950" b="0">
                 <a:solidFill>
                   <a:srgbClr val="F5F5EB"/>
@@ -5645,6 +5770,7 @@
           </a:p>
           <a:p xmlns:a="http://schemas.openxmlformats.org/drawingml/2006/main">
             <a:pPr>
+              <a:buNone/>
               <a:defRPr sz="1950" b="0">
                 <a:solidFill>
                   <a:srgbClr val="F5F5EB"/>
@@ -5668,6 +5794,7 @@
           </a:p>
           <a:p xmlns:a="http://schemas.openxmlformats.org/drawingml/2006/main">
             <a:pPr>
+              <a:buNone/>
               <a:defRPr sz="1950" b="0">
                 <a:solidFill>
                   <a:srgbClr val="F5F5EB"/>
@@ -5691,6 +5818,7 @@
           </a:p>
           <a:p xmlns:a="http://schemas.openxmlformats.org/drawingml/2006/main">
             <a:pPr>
+              <a:buNone/>
               <a:defRPr sz="1950" b="0">
                 <a:solidFill>
                   <a:srgbClr val="F5F5EB"/>
@@ -5757,6 +5885,7 @@
           </a:lstStyle>
           <a:p xmlns:a="http://schemas.openxmlformats.org/drawingml/2006/main">
             <a:pPr>
+              <a:buNone/>
               <a:defRPr sz="1950" b="1">
                 <a:solidFill>
                   <a:srgbClr val="E5BC83"/>
@@ -5780,6 +5909,7 @@
           </a:p>
           <a:p xmlns:a="http://schemas.openxmlformats.org/drawingml/2006/main">
             <a:pPr>
+              <a:buNone/>
               <a:defRPr sz="1950" b="1">
                 <a:solidFill>
                   <a:srgbClr val="E5BC83"/>
@@ -5803,6 +5933,7 @@
           </a:p>
           <a:p xmlns:a="http://schemas.openxmlformats.org/drawingml/2006/main">
             <a:pPr>
+              <a:buNone/>
               <a:defRPr sz="1950" b="1">
                 <a:solidFill>
                   <a:srgbClr val="E5BC83"/>
@@ -5898,6 +6029,7 @@
           </a:lstStyle>
           <a:p xmlns:a="http://schemas.openxmlformats.org/drawingml/2006/main">
             <a:pPr>
+              <a:buNone/>
               <a:defRPr sz="3600" b="1">
                 <a:solidFill>
                   <a:srgbClr val="F5F5EB"/>
@@ -5964,6 +6096,7 @@
           </a:lstStyle>
           <a:p xmlns:a="http://schemas.openxmlformats.org/drawingml/2006/main">
             <a:pPr>
+              <a:buNone/>
               <a:defRPr sz="1350" b="0">
                 <a:solidFill>
                   <a:srgbClr val="BDC9BF"/>
@@ -6030,6 +6163,7 @@
           </a:lstStyle>
           <a:p xmlns:a="http://schemas.openxmlformats.org/drawingml/2006/main">
             <a:pPr>
+              <a:buNone/>
               <a:defRPr sz="4050" b="1">
                 <a:solidFill>
                   <a:srgbClr val="C2EF7A"/>
@@ -6096,6 +6230,7 @@
           </a:lstStyle>
           <a:p xmlns:a="http://schemas.openxmlformats.org/drawingml/2006/main">
             <a:pPr>
+              <a:buNone/>
               <a:defRPr sz="4050" b="1">
                 <a:solidFill>
                   <a:srgbClr val="C2EF7A"/>
@@ -6162,6 +6297,7 @@
           </a:lstStyle>
           <a:p xmlns:a="http://schemas.openxmlformats.org/drawingml/2006/main">
             <a:pPr>
+              <a:buNone/>
               <a:defRPr sz="2400" b="0">
                 <a:solidFill>
                   <a:srgbClr val="F5F5EB"/>
@@ -6228,6 +6364,7 @@
           </a:lstStyle>
           <a:p xmlns:a="http://schemas.openxmlformats.org/drawingml/2006/main">
             <a:pPr>
+              <a:buNone/>
               <a:defRPr sz="2325" b="1">
                 <a:solidFill>
                   <a:srgbClr val="C2EF7A"/>
@@ -6294,6 +6431,7 @@
           </a:lstStyle>
           <a:p xmlns:a="http://schemas.openxmlformats.org/drawingml/2006/main">
             <a:pPr>
+              <a:buNone/>
               <a:defRPr sz="2175" b="0">
                 <a:solidFill>
                   <a:srgbClr val="F5F5EB"/>
@@ -6317,6 +6455,7 @@
           </a:p>
           <a:p xmlns:a="http://schemas.openxmlformats.org/drawingml/2006/main">
             <a:pPr>
+              <a:buNone/>
               <a:defRPr sz="2175" b="0">
                 <a:solidFill>
                   <a:srgbClr val="F5F5EB"/>
@@ -6340,6 +6479,7 @@
           </a:p>
           <a:p xmlns:a="http://schemas.openxmlformats.org/drawingml/2006/main">
             <a:pPr>
+              <a:buNone/>
               <a:defRPr sz="2175" b="0">
                 <a:solidFill>
                   <a:srgbClr val="F5F5EB"/>
@@ -6406,6 +6546,7 @@
           </a:lstStyle>
           <a:p xmlns:a="http://schemas.openxmlformats.org/drawingml/2006/main">
             <a:pPr>
+              <a:buNone/>
               <a:defRPr sz="2325" b="1">
                 <a:solidFill>
                   <a:srgbClr val="C2EF7A"/>
@@ -6472,6 +6613,7 @@
           </a:lstStyle>
           <a:p xmlns:a="http://schemas.openxmlformats.org/drawingml/2006/main">
             <a:pPr>
+              <a:buNone/>
               <a:defRPr sz="2175" b="0">
                 <a:solidFill>
                   <a:srgbClr val="F5F5EB"/>
@@ -6495,6 +6637,7 @@
           </a:p>
           <a:p xmlns:a="http://schemas.openxmlformats.org/drawingml/2006/main">
             <a:pPr>
+              <a:buNone/>
               <a:defRPr sz="2175" b="0">
                 <a:solidFill>
                   <a:srgbClr val="F5F5EB"/>
@@ -6518,6 +6661,7 @@
           </a:p>
           <a:p xmlns:a="http://schemas.openxmlformats.org/drawingml/2006/main">
             <a:pPr>
+              <a:buNone/>
               <a:defRPr sz="2175" b="0">
                 <a:solidFill>
                   <a:srgbClr val="F5F5EB"/>
@@ -6584,6 +6728,7 @@
           </a:lstStyle>
           <a:p xmlns:a="http://schemas.openxmlformats.org/drawingml/2006/main">
             <a:pPr>
+              <a:buNone/>
               <a:defRPr sz="1800" b="0">
                 <a:solidFill>
                   <a:srgbClr val="E5BC83"/>
@@ -6679,6 +6824,7 @@
           </a:lstStyle>
           <a:p xmlns:a="http://schemas.openxmlformats.org/drawingml/2006/main">
             <a:pPr>
+              <a:buNone/>
               <a:defRPr sz="3600" b="1">
                 <a:solidFill>
                   <a:srgbClr val="F5F5EB"/>
@@ -6745,6 +6891,7 @@
           </a:lstStyle>
           <a:p xmlns:a="http://schemas.openxmlformats.org/drawingml/2006/main">
             <a:pPr>
+              <a:buNone/>
               <a:defRPr sz="1350" b="0">
                 <a:solidFill>
                   <a:srgbClr val="BDC9BF"/>
@@ -6811,6 +6958,7 @@
           </a:lstStyle>
           <a:p xmlns:a="http://schemas.openxmlformats.org/drawingml/2006/main">
             <a:pPr>
+              <a:buNone/>
               <a:defRPr sz="2400" b="1">
                 <a:solidFill>
                   <a:srgbClr val="C2EF7A"/>
@@ -6877,6 +7025,7 @@
           </a:lstStyle>
           <a:p xmlns:a="http://schemas.openxmlformats.org/drawingml/2006/main">
             <a:pPr>
+              <a:buNone/>
               <a:defRPr sz="2325" b="0">
                 <a:solidFill>
                   <a:srgbClr val="F5F5EB"/>
@@ -6900,6 +7049,7 @@
           </a:p>
           <a:p xmlns:a="http://schemas.openxmlformats.org/drawingml/2006/main">
             <a:pPr>
+              <a:buNone/>
               <a:defRPr sz="2325" b="0">
                 <a:solidFill>
                   <a:srgbClr val="F5F5EB"/>
@@ -6923,6 +7073,7 @@
           </a:p>
           <a:p xmlns:a="http://schemas.openxmlformats.org/drawingml/2006/main">
             <a:pPr>
+              <a:buNone/>
               <a:defRPr sz="2325" b="0">
                 <a:solidFill>
                   <a:srgbClr val="F5F5EB"/>
@@ -6946,6 +7097,7 @@
           </a:p>
           <a:p xmlns:a="http://schemas.openxmlformats.org/drawingml/2006/main">
             <a:pPr>
+              <a:buNone/>
               <a:defRPr sz="2325" b="0">
                 <a:solidFill>
                   <a:srgbClr val="F5F5EB"/>
@@ -7012,6 +7164,7 @@
           </a:lstStyle>
           <a:p xmlns:a="http://schemas.openxmlformats.org/drawingml/2006/main">
             <a:pPr>
+              <a:buNone/>
               <a:defRPr sz="2250" b="1">
                 <a:solidFill>
                   <a:srgbClr val="C2EF7A"/>
@@ -7078,6 +7231,7 @@
           </a:lstStyle>
           <a:p xmlns:a="http://schemas.openxmlformats.org/drawingml/2006/main">
             <a:pPr>
+              <a:buNone/>
               <a:defRPr sz="1875" b="0">
                 <a:solidFill>
                   <a:srgbClr val="BDC9BF"/>
@@ -7101,6 +7255,7 @@
           </a:p>
           <a:p xmlns:a="http://schemas.openxmlformats.org/drawingml/2006/main">
             <a:pPr>
+              <a:buNone/>
               <a:defRPr sz="1875" b="0">
                 <a:solidFill>
                   <a:srgbClr val="BDC9BF"/>
@@ -7167,6 +7322,7 @@
           </a:lstStyle>
           <a:p xmlns:a="http://schemas.openxmlformats.org/drawingml/2006/main">
             <a:pPr>
+              <a:buNone/>
               <a:defRPr sz="1950" b="0">
                 <a:solidFill>
                   <a:srgbClr val="F5F5EB"/>

</xml_diff>